<commit_message>
chore: pre-commit hook enforcing ruff and pytest
A hook in .githooks/ runs ruff check, ruff format --check and pytest
before every commit; enable it once per clone with
git config core.hooksPath .githooks.

Co-authored-by: Claude <noreply@anthropic.com>
</commit_message>
<xml_diff>
--- a/docs/presentation/elevator-dispatch.pptx
+++ b/docs/presentation/elevator-dispatch.pptx
@@ -1660,10 +1660,8 @@
           <a:lstStyle/>
           <a:p>
             <a:r>
-              <a:rPr lang="en-US" dirty="0"/>
               <a:t>Before the demo and the numbers: why you should believe them. 192 tests at six levels — unit tests for every observable assumption, a structural no-peek-ahead test, property-based invariants over random buildings, golden statistics that now pin every committed result so a behaviour change forces a documentation change, end-to-end CLI checks, and a conformance matrix that runs the JavaScript port on all fifty scenario-by-variant combinations and asserts identical positions, events and car usage. Then an adversarial review of the whole repository: forty-one findings, no blockers, eight major; sixteen changed code or tests, twenty-one changed documents, four resolved otherwise. The review also re-drew every pattern with twenty fresh seeds — the headline held, two secondary claims did not. Sceptic’s question: two engines agreeing only proves they share the same bugs. Correct — conformance proves equality, not correctness; correctness comes from the unit and property tests and from a 400-seed fuzz, which broke no invariant.</a:t>
             </a:r>
-            <a:endParaRPr lang="en-US" dirty="0"/>
           </a:p>
         </p:txBody>
       </p:sp>
@@ -13331,7 +13329,7 @@
                 <a:ea typeface="Arial" pitchFamily="34" charset="-122"/>
                 <a:cs typeface="Arial" pitchFamily="34" charset="-120"/>
               </a:rPr>
-              <a:t>Adversarial review; twenty fresh seeds per pattern.</a:t>
+              <a:t>Two reviews by review passs of the same model; twenty fresh seeds per pattern.</a:t>
             </a:r>
             <a:endParaRPr lang="en-US" sz="1800" dirty="0"/>
           </a:p>
@@ -13372,7 +13370,7 @@
                 <a:ea typeface="Courier New" pitchFamily="34" charset="-122"/>
                 <a:cs typeface="Courier New" pitchFamily="34" charset="-120"/>
               </a:rPr>
-              <a:t>assistant</a:t>
+              <a:t>review passs, same model</a:t>
             </a:r>
             <a:endParaRPr lang="en-US" sz="1800" dirty="0"/>
           </a:p>

</xml_diff>